<commit_message>
docs: add investor pitch decks, outreach material, and action release notes
Add the four domain pitch decks (automotive, aviation, medical, railway),
outreach email templates, ready-to-post Reddit content, and GitHub Action
v0.1.0 release documentation. These are external-facing materials for
design-partner and pilot conversations.

Co-Authored-By: Claude Opus 4.8 <noreply@anthropic.com>
</commit_message>
<xml_diff>
--- a/AVERA_Pitch_Automotive.pptx
+++ b/AVERA_Pitch_Automotive.pptx
@@ -1606,6 +1606,10 @@
           </a:solidFill>
           <a:ln/>
         </p:spPr>
+        <p:txBody>
+          <a:bodyPr/>
+          <a:p/>
+        </p:txBody>
       </p:sp>
       <p:sp>
         <p:nvSpPr>
@@ -1799,6 +1803,10 @@
           </a:solidFill>
           <a:ln/>
         </p:spPr>
+        <p:txBody>
+          <a:bodyPr/>
+          <a:p/>
+        </p:txBody>
       </p:sp>
       <p:sp>
         <p:nvSpPr>
@@ -1833,7 +1841,7 @@
                 <a:ea typeface="Calibri" pitchFamily="34" charset="-122"/>
                 <a:cs typeface="Calibri" pitchFamily="34" charset="-120"/>
               </a:rPr>
-              <a:t>Live Demo: avera-demo.up.railway.app   ·   Contact: mgaloyan79@gmail.com</a:t>
+              <a:t>Live Demo: avera-production.up.railway.app   ·   Contact: mgaloyan79@gmail.com</a:t>
             </a:r>
             <a:endParaRPr lang="en-US" sz="1000" dirty="0"/>
           </a:p>
@@ -1890,6 +1898,10 @@
           </a:solidFill>
           <a:ln/>
         </p:spPr>
+        <p:txBody>
+          <a:bodyPr/>
+          <a:p/>
+        </p:txBody>
       </p:sp>
       <p:sp>
         <p:nvSpPr>
@@ -1956,6 +1968,10 @@
             </a:outerShdw>
           </a:effectLst>
         </p:spPr>
+        <p:txBody>
+          <a:bodyPr/>
+          <a:p/>
+        </p:txBody>
       </p:sp>
       <p:sp>
         <p:nvSpPr>
@@ -1976,6 +1992,10 @@
           </a:solidFill>
           <a:ln/>
         </p:spPr>
+        <p:txBody>
+          <a:bodyPr/>
+          <a:p/>
+        </p:txBody>
       </p:sp>
       <p:sp>
         <p:nvSpPr>
@@ -2156,6 +2176,10 @@
             </a:outerShdw>
           </a:effectLst>
         </p:spPr>
+        <p:txBody>
+          <a:bodyPr/>
+          <a:p/>
+        </p:txBody>
       </p:sp>
       <p:sp>
         <p:nvSpPr>
@@ -2176,6 +2200,10 @@
           </a:solidFill>
           <a:ln/>
         </p:spPr>
+        <p:txBody>
+          <a:bodyPr/>
+          <a:p/>
+        </p:txBody>
       </p:sp>
       <p:sp>
         <p:nvSpPr>
@@ -2356,6 +2384,10 @@
             </a:outerShdw>
           </a:effectLst>
         </p:spPr>
+        <p:txBody>
+          <a:bodyPr/>
+          <a:p/>
+        </p:txBody>
       </p:sp>
       <p:sp>
         <p:nvSpPr>
@@ -2376,6 +2408,10 @@
           </a:solidFill>
           <a:ln/>
         </p:spPr>
+        <p:txBody>
+          <a:bodyPr/>
+          <a:p/>
+        </p:txBody>
       </p:sp>
       <p:sp>
         <p:nvSpPr>
@@ -2722,6 +2758,10 @@
             </a:outerShdw>
           </a:effectLst>
         </p:spPr>
+        <p:txBody>
+          <a:bodyPr/>
+          <a:p/>
+        </p:txBody>
       </p:sp>
       <p:sp>
         <p:nvSpPr>
@@ -2742,6 +2782,10 @@
           </a:solidFill>
           <a:ln/>
         </p:spPr>
+        <p:txBody>
+          <a:bodyPr/>
+          <a:p/>
+        </p:txBody>
       </p:sp>
       <p:sp>
         <p:nvSpPr>
@@ -2886,6 +2930,10 @@
             </a:outerShdw>
           </a:effectLst>
         </p:spPr>
+        <p:txBody>
+          <a:bodyPr/>
+          <a:p/>
+        </p:txBody>
       </p:sp>
       <p:sp>
         <p:nvSpPr>
@@ -2906,6 +2954,10 @@
           </a:solidFill>
           <a:ln/>
         </p:spPr>
+        <p:txBody>
+          <a:bodyPr/>
+          <a:p/>
+        </p:txBody>
       </p:sp>
       <p:sp>
         <p:nvSpPr>
@@ -3050,6 +3102,10 @@
             </a:outerShdw>
           </a:effectLst>
         </p:spPr>
+        <p:txBody>
+          <a:bodyPr/>
+          <a:p/>
+        </p:txBody>
       </p:sp>
       <p:sp>
         <p:nvSpPr>
@@ -3070,6 +3126,10 @@
           </a:solidFill>
           <a:ln/>
         </p:spPr>
+        <p:txBody>
+          <a:bodyPr/>
+          <a:p/>
+        </p:txBody>
       </p:sp>
       <p:sp>
         <p:nvSpPr>
@@ -3214,6 +3274,10 @@
             </a:outerShdw>
           </a:effectLst>
         </p:spPr>
+        <p:txBody>
+          <a:bodyPr/>
+          <a:p/>
+        </p:txBody>
       </p:sp>
       <p:sp>
         <p:nvSpPr>
@@ -3234,6 +3298,10 @@
           </a:solidFill>
           <a:ln/>
         </p:spPr>
+        <p:txBody>
+          <a:bodyPr/>
+          <a:p/>
+        </p:txBody>
       </p:sp>
       <p:sp>
         <p:nvSpPr>
@@ -3403,6 +3471,10 @@
           </a:solidFill>
           <a:ln/>
         </p:spPr>
+        <p:txBody>
+          <a:bodyPr/>
+          <a:p/>
+        </p:txBody>
       </p:sp>
       <p:sp>
         <p:nvSpPr>
@@ -3462,6 +3534,10 @@
           </a:solidFill>
           <a:ln/>
         </p:spPr>
+        <p:txBody>
+          <a:bodyPr/>
+          <a:p/>
+        </p:txBody>
       </p:sp>
       <p:sp>
         <p:nvSpPr>
@@ -3482,6 +3558,10 @@
           </a:solidFill>
           <a:ln/>
         </p:spPr>
+        <p:txBody>
+          <a:bodyPr/>
+          <a:p/>
+        </p:txBody>
       </p:sp>
       <p:sp>
         <p:nvSpPr>
@@ -3619,6 +3699,10 @@
           </a:solidFill>
           <a:ln/>
         </p:spPr>
+        <p:txBody>
+          <a:bodyPr/>
+          <a:p/>
+        </p:txBody>
       </p:sp>
       <p:sp>
         <p:nvSpPr>
@@ -3639,6 +3723,10 @@
           </a:solidFill>
           <a:ln/>
         </p:spPr>
+        <p:txBody>
+          <a:bodyPr/>
+          <a:p/>
+        </p:txBody>
       </p:sp>
       <p:sp>
         <p:nvSpPr>
@@ -3776,6 +3864,10 @@
           </a:solidFill>
           <a:ln/>
         </p:spPr>
+        <p:txBody>
+          <a:bodyPr/>
+          <a:p/>
+        </p:txBody>
       </p:sp>
       <p:sp>
         <p:nvSpPr>
@@ -3796,6 +3888,10 @@
           </a:solidFill>
           <a:ln/>
         </p:spPr>
+        <p:txBody>
+          <a:bodyPr/>
+          <a:p/>
+        </p:txBody>
       </p:sp>
       <p:sp>
         <p:nvSpPr>
@@ -3933,6 +4029,10 @@
           </a:solidFill>
           <a:ln/>
         </p:spPr>
+        <p:txBody>
+          <a:bodyPr/>
+          <a:p/>
+        </p:txBody>
       </p:sp>
       <p:sp>
         <p:nvSpPr>
@@ -4187,6 +4287,10 @@
             </a:outerShdw>
           </a:effectLst>
         </p:spPr>
+        <p:txBody>
+          <a:bodyPr/>
+          <a:p/>
+        </p:txBody>
       </p:sp>
       <p:sp>
         <p:nvSpPr>
@@ -4331,6 +4435,10 @@
             </a:outerShdw>
           </a:effectLst>
         </p:spPr>
+        <p:txBody>
+          <a:bodyPr/>
+          <a:p/>
+        </p:txBody>
       </p:sp>
       <p:sp>
         <p:nvSpPr>
@@ -4475,6 +4583,10 @@
             </a:outerShdw>
           </a:effectLst>
         </p:spPr>
+        <p:txBody>
+          <a:bodyPr/>
+          <a:p/>
+        </p:txBody>
       </p:sp>
       <p:sp>
         <p:nvSpPr>
@@ -4619,6 +4731,10 @@
             </a:outerShdw>
           </a:effectLst>
         </p:spPr>
+        <p:txBody>
+          <a:bodyPr/>
+          <a:p/>
+        </p:txBody>
       </p:sp>
       <p:sp>
         <p:nvSpPr>
@@ -4827,6 +4943,10 @@
           </a:solidFill>
           <a:ln/>
         </p:spPr>
+        <p:txBody>
+          <a:bodyPr/>
+          <a:p/>
+        </p:txBody>
       </p:sp>
       <p:sp>
         <p:nvSpPr>
@@ -6580,6 +6700,10 @@
             </a:outerShdw>
           </a:effectLst>
         </p:spPr>
+        <p:txBody>
+          <a:bodyPr/>
+          <a:p/>
+        </p:txBody>
       </p:sp>
       <p:sp>
         <p:nvSpPr>
@@ -6614,7 +6738,7 @@
                 <a:ea typeface="Consolas" pitchFamily="34" charset="-122"/>
                 <a:cs typeface="Consolas" pitchFamily="34" charset="-120"/>
               </a:rPr>
-              <a:t>https://avera-demo.up.railway.app</a:t>
+              <a:t>https://avera-production.up.railway.app</a:t>
             </a:r>
             <a:endParaRPr lang="en-US" sz="2200" dirty="0"/>
           </a:p>
@@ -6873,6 +6997,10 @@
           </a:solidFill>
           <a:ln/>
         </p:spPr>
+        <p:txBody>
+          <a:bodyPr/>
+          <a:p/>
+        </p:txBody>
       </p:sp>
       <p:sp>
         <p:nvSpPr>
@@ -6964,6 +7092,10 @@
           </a:solidFill>
           <a:ln/>
         </p:spPr>
+        <p:txBody>
+          <a:bodyPr/>
+          <a:p/>
+        </p:txBody>
       </p:sp>
       <p:sp>
         <p:nvSpPr>
@@ -7030,6 +7162,10 @@
             </a:outerShdw>
           </a:effectLst>
         </p:spPr>
+        <p:txBody>
+          <a:bodyPr/>
+          <a:p/>
+        </p:txBody>
       </p:sp>
       <p:sp>
         <p:nvSpPr>
@@ -7050,6 +7186,10 @@
           </a:solidFill>
           <a:ln/>
         </p:spPr>
+        <p:txBody>
+          <a:bodyPr/>
+          <a:p/>
+        </p:txBody>
       </p:sp>
       <p:sp>
         <p:nvSpPr>
@@ -7367,6 +7507,10 @@
             </a:outerShdw>
           </a:effectLst>
         </p:spPr>
+        <p:txBody>
+          <a:bodyPr/>
+          <a:p/>
+        </p:txBody>
       </p:sp>
       <p:sp>
         <p:nvSpPr>
@@ -7387,6 +7531,10 @@
           </a:solidFill>
           <a:ln/>
         </p:spPr>
+        <p:txBody>
+          <a:bodyPr/>
+          <a:p/>
+        </p:txBody>
       </p:sp>
       <p:sp>
         <p:nvSpPr>
@@ -7704,6 +7852,10 @@
             </a:outerShdw>
           </a:effectLst>
         </p:spPr>
+        <p:txBody>
+          <a:bodyPr/>
+          <a:p/>
+        </p:txBody>
       </p:sp>
       <p:sp>
         <p:nvSpPr>
@@ -7724,6 +7876,10 @@
           </a:solidFill>
           <a:ln/>
         </p:spPr>
+        <p:txBody>
+          <a:bodyPr/>
+          <a:p/>
+        </p:txBody>
       </p:sp>
       <p:sp>
         <p:nvSpPr>
@@ -8066,6 +8222,10 @@
           </a:solidFill>
           <a:ln/>
         </p:spPr>
+        <p:txBody>
+          <a:bodyPr/>
+          <a:p/>
+        </p:txBody>
       </p:sp>
       <p:sp>
         <p:nvSpPr>
@@ -8171,6 +8331,10 @@
             </a:outerShdw>
           </a:effectLst>
         </p:spPr>
+        <p:txBody>
+          <a:bodyPr/>
+          <a:p/>
+        </p:txBody>
       </p:sp>
       <p:sp>
         <p:nvSpPr>
@@ -8280,7 +8444,7 @@
                 <a:ea typeface="Calibri" pitchFamily="34" charset="-122"/>
                 <a:cs typeface="Calibri" pitchFamily="34" charset="-120"/>
               </a:rPr>
-              <a:t>avera-demo.up.railway.app</a:t>
+              <a:t>avera-production.up.railway.app</a:t>
             </a:r>
             <a:endParaRPr lang="en-US" sz="1000" dirty="0"/>
           </a:p>
@@ -8312,6 +8476,10 @@
             </a:outerShdw>
           </a:effectLst>
         </p:spPr>
+        <p:txBody>
+          <a:bodyPr/>
+          <a:p/>
+        </p:txBody>
       </p:sp>
       <p:sp>
         <p:nvSpPr>
@@ -8453,6 +8621,10 @@
             </a:outerShdw>
           </a:effectLst>
         </p:spPr>
+        <p:txBody>
+          <a:bodyPr/>
+          <a:p/>
+        </p:txBody>
       </p:sp>
       <p:sp>
         <p:nvSpPr>

</xml_diff>